<commit_message>
Domus Energia (negócio): textos do plano e da apresentação alinhados com o fluxo novo (propostas na bolsa, três pontos de controlo, gerente)
Co-Authored-By: Claude Opus 5.5 <noreply@anthropic.com>
</commit_message>
<xml_diff>
--- a/domus-energia/negocio/Domus_Energia_Ideia_de_Negocio_v2.pptx
+++ b/domus-energia/negocio/Domus_Energia_Ideia_de_Negocio_v2.pptx
@@ -2247,7 +2247,7 @@
           <a:p>
             <a:r>
               <a:rPr lang="en-US" dirty="0"/>
-              <a:t>Seguir os números de 1 a 8. No passo 5, se o cliente não aceitar, o pedido volta ao CEO, que retifica e volta a pôr na bolsa, ou desiste. O eletricista vai a casa do cliente em nome da empresa.</a:t>
+              <a:t>Seguir os números de 1 a 8. No passo 5, se o cliente não aceitar, o pedido volta ao gerente, que retifica e volta a pôr na bolsa, ou desiste. O eletricista vai a casa do cliente em nome da empresa.</a:t>
             </a:r>
             <a:endParaRPr lang="en-US" dirty="0"/>
           </a:p>
@@ -4450,7 +4450,7 @@
                 <a:ea typeface="Calibri" pitchFamily="34" charset="-122"/>
                 <a:cs typeface="Calibri" pitchFamily="34" charset="-120"/>
               </a:rPr>
-              <a:t>Ensaios, fotografias, revisão por outro eletricista, seguro</a:t>
+              <a:t>Validação à entrada, fotos e ensaios, confirmação do cliente, seguro</a:t>
             </a:r>
             <a:endParaRPr lang="en-US" sz="1200" dirty="0"/>
           </a:p>
@@ -11504,7 +11504,7 @@
                 <a:ea typeface="Calibri" pitchFamily="34" charset="-122"/>
                 <a:cs typeface="Calibri" pitchFamily="34" charset="-120"/>
               </a:rPr>
-              <a:t>Quadros novos; revê as obras dos colegas</a:t>
+              <a:t>Quadros novos e ampliações</a:t>
             </a:r>
             <a:endParaRPr lang="en-US" sz="1100" dirty="0"/>
           </a:p>
@@ -11996,7 +11996,7 @@
                 <a:ea typeface="Calibri" pitchFamily="34" charset="-122"/>
                 <a:cs typeface="Calibri" pitchFamily="34" charset="-120"/>
               </a:rPr>
-              <a:t>Parceiros independentes, pagos por obra: 70 % da mão de obra. Quem faz a obra não é quem a revê. Os melhores passam a contrato quando houver volume.</a:t>
+              <a:t>Parceiros independentes, pagos por obra: 70 % da mão de obra. Qualidade em três pontos: validação do gerente, fotos e ensaios, confirmação do cliente. Os melhores passam a contrato quando houver volume.</a:t>
             </a:r>
             <a:endParaRPr lang="en-US" sz="1100" dirty="0"/>
           </a:p>
@@ -12446,7 +12446,7 @@
                 <a:ea typeface="Calibri" pitchFamily="34" charset="-122"/>
                 <a:cs typeface="Calibri" pitchFamily="34" charset="-120"/>
               </a:rPr>
-              <a:t>Aceita e paga o sinal, que inclui a visita. Se não aceitar, diz porquê e o pedido volta ao CEO.</a:t>
+              <a:t>Aceita e paga o sinal, que inclui a visita. Se não aceitar, diz porquê e o pedido volta ao gerente.</a:t>
             </a:r>
             <a:endParaRPr lang="en-US" sz="1050" dirty="0"/>
           </a:p>
@@ -12649,7 +12649,7 @@
                 <a:ea typeface="Calibri" pitchFamily="34" charset="-122"/>
                 <a:cs typeface="Calibri" pitchFamily="34" charset="-120"/>
               </a:rPr>
-              <a:t>CEO</a:t>
+              <a:t>GERENTE (CEO)</a:t>
             </a:r>
             <a:endParaRPr lang="en-US" sz="1200" dirty="0"/>
           </a:p>

</xml_diff>